<commit_message>
Update slides with Built by Shakib author tag
</commit_message>
<xml_diff>
--- a/Multilingual_HTR_Presentation.pptx
+++ b/Multilingual_HTR_Presentation.pptx
@@ -3112,6 +3112,42 @@
         </p:nvSpPr>
         <p:spPr>
           <a:xfrm>
+            <a:off x="9601200" y="6309360"/>
+            <a:ext cx="2057400" cy="365760"/>
+          </a:xfrm>
+          <a:prstGeom prst="rect">
+            <a:avLst/>
+          </a:prstGeom>
+          <a:noFill/>
+        </p:spPr>
+        <p:txBody>
+          <a:bodyPr wrap="none">
+            <a:spAutoFit/>
+          </a:bodyPr>
+          <a:lstStyle/>
+          <a:p>
+            <a:pPr algn="r">
+              <a:defRPr sz="850" b="1">
+                <a:solidFill>
+                  <a:srgbClr val="94A3B8"/>
+                </a:solidFill>
+                <a:latin typeface="Trebuchet MS"/>
+              </a:defRPr>
+            </a:pPr>
+            <a:r>
+              <a:t>BUILT BY SHAKIB</a:t>
+            </a:r>
+          </a:p>
+        </p:txBody>
+      </p:sp>
+      <p:sp>
+        <p:nvSpPr>
+          <p:cNvPr id="3" name="TextBox 2"/>
+          <p:cNvSpPr txBox="1"/>
+          <p:nvPr/>
+        </p:nvSpPr>
+        <p:spPr>
+          <a:xfrm>
             <a:off x="731520" y="1371600"/>
             <a:ext cx="5943600" cy="4572000"/>
           </a:xfrm>
@@ -3187,7 +3223,7 @@
       </p:sp>
       <p:sp>
         <p:nvSpPr>
-          <p:cNvPr id="3" name="TextBox 2"/>
+          <p:cNvPr id="4" name="TextBox 3"/>
           <p:cNvSpPr txBox="1"/>
           <p:nvPr/>
         </p:nvSpPr>
@@ -3236,7 +3272,7 @@
       </p:sp>
       <p:sp>
         <p:nvSpPr>
-          <p:cNvPr id="4" name="Rounded Rectangle 3"/>
+          <p:cNvPr id="5" name="Rounded Rectangle 4"/>
           <p:cNvSpPr/>
           <p:nvPr/>
         </p:nvSpPr>
@@ -3281,7 +3317,7 @@
       </p:sp>
       <p:sp>
         <p:nvSpPr>
-          <p:cNvPr id="5" name="TextBox 4"/>
+          <p:cNvPr id="6" name="TextBox 5"/>
           <p:cNvSpPr txBox="1"/>
           <p:nvPr/>
         </p:nvSpPr>
@@ -3417,6 +3453,42 @@
         </p:nvSpPr>
         <p:spPr>
           <a:xfrm>
+            <a:off x="9601200" y="6309360"/>
+            <a:ext cx="2057400" cy="365760"/>
+          </a:xfrm>
+          <a:prstGeom prst="rect">
+            <a:avLst/>
+          </a:prstGeom>
+          <a:noFill/>
+        </p:spPr>
+        <p:txBody>
+          <a:bodyPr wrap="none">
+            <a:spAutoFit/>
+          </a:bodyPr>
+          <a:lstStyle/>
+          <a:p>
+            <a:pPr algn="r">
+              <a:defRPr sz="850" b="1">
+                <a:solidFill>
+                  <a:srgbClr val="94A3B8"/>
+                </a:solidFill>
+                <a:latin typeface="Trebuchet MS"/>
+              </a:defRPr>
+            </a:pPr>
+            <a:r>
+              <a:t>BUILT BY SHAKIB</a:t>
+            </a:r>
+          </a:p>
+        </p:txBody>
+      </p:sp>
+      <p:sp>
+        <p:nvSpPr>
+          <p:cNvPr id="3" name="TextBox 2"/>
+          <p:cNvSpPr txBox="1"/>
+          <p:nvPr/>
+        </p:nvSpPr>
+        <p:spPr>
+          <a:xfrm>
             <a:off x="548640" y="365760"/>
             <a:ext cx="10972800" cy="365760"/>
           </a:xfrm>
@@ -3447,7 +3519,7 @@
       </p:sp>
       <p:sp>
         <p:nvSpPr>
-          <p:cNvPr id="3" name="TextBox 2"/>
+          <p:cNvPr id="4" name="TextBox 3"/>
           <p:cNvSpPr txBox="1"/>
           <p:nvPr/>
         </p:nvSpPr>
@@ -3483,7 +3555,7 @@
       </p:sp>
       <p:sp>
         <p:nvSpPr>
-          <p:cNvPr id="4" name="Rectangle 3"/>
+          <p:cNvPr id="5" name="Rectangle 4"/>
           <p:cNvSpPr/>
           <p:nvPr/>
         </p:nvSpPr>
@@ -3526,7 +3598,7 @@
       </p:sp>
       <p:sp>
         <p:nvSpPr>
-          <p:cNvPr id="5" name="Rounded Rectangle 4"/>
+          <p:cNvPr id="6" name="Rounded Rectangle 5"/>
           <p:cNvSpPr/>
           <p:nvPr/>
         </p:nvSpPr>
@@ -3571,7 +3643,7 @@
       </p:sp>
       <p:sp>
         <p:nvSpPr>
-          <p:cNvPr id="6" name="TextBox 5"/>
+          <p:cNvPr id="7" name="TextBox 6"/>
           <p:cNvSpPr txBox="1"/>
           <p:nvPr/>
         </p:nvSpPr>
@@ -3657,7 +3729,7 @@
       </p:sp>
       <p:sp>
         <p:nvSpPr>
-          <p:cNvPr id="7" name="Rounded Rectangle 6"/>
+          <p:cNvPr id="8" name="Rounded Rectangle 7"/>
           <p:cNvSpPr/>
           <p:nvPr/>
         </p:nvSpPr>
@@ -3702,7 +3774,7 @@
       </p:sp>
       <p:sp>
         <p:nvSpPr>
-          <p:cNvPr id="8" name="TextBox 7"/>
+          <p:cNvPr id="9" name="TextBox 8"/>
           <p:cNvSpPr txBox="1"/>
           <p:nvPr/>
         </p:nvSpPr>
@@ -3788,7 +3860,7 @@
       </p:sp>
       <p:sp>
         <p:nvSpPr>
-          <p:cNvPr id="9" name="TextBox 8"/>
+          <p:cNvPr id="10" name="TextBox 9"/>
           <p:cNvSpPr txBox="1"/>
           <p:nvPr/>
         </p:nvSpPr>
@@ -3855,6 +3927,42 @@
         </p:nvSpPr>
         <p:spPr>
           <a:xfrm>
+            <a:off x="9601200" y="6309360"/>
+            <a:ext cx="2057400" cy="365760"/>
+          </a:xfrm>
+          <a:prstGeom prst="rect">
+            <a:avLst/>
+          </a:prstGeom>
+          <a:noFill/>
+        </p:spPr>
+        <p:txBody>
+          <a:bodyPr wrap="none">
+            <a:spAutoFit/>
+          </a:bodyPr>
+          <a:lstStyle/>
+          <a:p>
+            <a:pPr algn="r">
+              <a:defRPr sz="850" b="1">
+                <a:solidFill>
+                  <a:srgbClr val="94A3B8"/>
+                </a:solidFill>
+                <a:latin typeface="Trebuchet MS"/>
+              </a:defRPr>
+            </a:pPr>
+            <a:r>
+              <a:t>BUILT BY SHAKIB</a:t>
+            </a:r>
+          </a:p>
+        </p:txBody>
+      </p:sp>
+      <p:sp>
+        <p:nvSpPr>
+          <p:cNvPr id="3" name="TextBox 2"/>
+          <p:cNvSpPr txBox="1"/>
+          <p:nvPr/>
+        </p:nvSpPr>
+        <p:spPr>
+          <a:xfrm>
             <a:off x="548640" y="365760"/>
             <a:ext cx="10972800" cy="365760"/>
           </a:xfrm>
@@ -3885,7 +3993,7 @@
       </p:sp>
       <p:sp>
         <p:nvSpPr>
-          <p:cNvPr id="3" name="TextBox 2"/>
+          <p:cNvPr id="4" name="TextBox 3"/>
           <p:cNvSpPr txBox="1"/>
           <p:nvPr/>
         </p:nvSpPr>
@@ -3921,7 +4029,7 @@
       </p:sp>
       <p:sp>
         <p:nvSpPr>
-          <p:cNvPr id="4" name="Rectangle 3"/>
+          <p:cNvPr id="5" name="Rectangle 4"/>
           <p:cNvSpPr/>
           <p:nvPr/>
         </p:nvSpPr>
@@ -3964,7 +4072,7 @@
       </p:sp>
       <p:sp>
         <p:nvSpPr>
-          <p:cNvPr id="5" name="Rounded Rectangle 4"/>
+          <p:cNvPr id="6" name="Rounded Rectangle 5"/>
           <p:cNvSpPr/>
           <p:nvPr/>
         </p:nvSpPr>
@@ -4009,7 +4117,7 @@
       </p:sp>
       <p:sp>
         <p:nvSpPr>
-          <p:cNvPr id="6" name="TextBox 5"/>
+          <p:cNvPr id="7" name="TextBox 6"/>
           <p:cNvSpPr txBox="1"/>
           <p:nvPr/>
         </p:nvSpPr>
@@ -4057,7 +4165,7 @@
       </p:sp>
       <p:sp>
         <p:nvSpPr>
-          <p:cNvPr id="7" name="Rounded Rectangle 6"/>
+          <p:cNvPr id="8" name="Rounded Rectangle 7"/>
           <p:cNvSpPr/>
           <p:nvPr/>
         </p:nvSpPr>
@@ -4102,7 +4210,7 @@
       </p:sp>
       <p:sp>
         <p:nvSpPr>
-          <p:cNvPr id="8" name="TextBox 7"/>
+          <p:cNvPr id="9" name="TextBox 8"/>
           <p:cNvSpPr txBox="1"/>
           <p:nvPr/>
         </p:nvSpPr>
@@ -4150,7 +4258,7 @@
       </p:sp>
       <p:sp>
         <p:nvSpPr>
-          <p:cNvPr id="9" name="Rounded Rectangle 8"/>
+          <p:cNvPr id="10" name="Rounded Rectangle 9"/>
           <p:cNvSpPr/>
           <p:nvPr/>
         </p:nvSpPr>
@@ -4195,7 +4303,7 @@
       </p:sp>
       <p:sp>
         <p:nvSpPr>
-          <p:cNvPr id="10" name="TextBox 9"/>
+          <p:cNvPr id="11" name="TextBox 10"/>
           <p:cNvSpPr txBox="1"/>
           <p:nvPr/>
         </p:nvSpPr>
@@ -4243,7 +4351,7 @@
       </p:sp>
       <p:sp>
         <p:nvSpPr>
-          <p:cNvPr id="11" name="Rounded Rectangle 10"/>
+          <p:cNvPr id="12" name="Rounded Rectangle 11"/>
           <p:cNvSpPr/>
           <p:nvPr/>
         </p:nvSpPr>
@@ -4288,7 +4396,7 @@
       </p:sp>
       <p:sp>
         <p:nvSpPr>
-          <p:cNvPr id="12" name="TextBox 11"/>
+          <p:cNvPr id="13" name="TextBox 12"/>
           <p:cNvSpPr txBox="1"/>
           <p:nvPr/>
         </p:nvSpPr>
@@ -4336,7 +4444,7 @@
       </p:sp>
       <p:sp>
         <p:nvSpPr>
-          <p:cNvPr id="13" name="TextBox 12"/>
+          <p:cNvPr id="14" name="TextBox 13"/>
           <p:cNvSpPr txBox="1"/>
           <p:nvPr/>
         </p:nvSpPr>
@@ -4371,7 +4479,7 @@
       </p:sp>
       <p:sp>
         <p:nvSpPr>
-          <p:cNvPr id="14" name="Rounded Rectangle 13"/>
+          <p:cNvPr id="15" name="Rounded Rectangle 14"/>
           <p:cNvSpPr/>
           <p:nvPr/>
         </p:nvSpPr>
@@ -4416,7 +4524,7 @@
       </p:sp>
       <p:sp>
         <p:nvSpPr>
-          <p:cNvPr id="15" name="TextBox 14"/>
+          <p:cNvPr id="16" name="TextBox 15"/>
           <p:cNvSpPr txBox="1"/>
           <p:nvPr/>
         </p:nvSpPr>
@@ -4475,7 +4583,7 @@
       </p:sp>
       <p:sp>
         <p:nvSpPr>
-          <p:cNvPr id="16" name="Rounded Rectangle 15"/>
+          <p:cNvPr id="17" name="Rounded Rectangle 16"/>
           <p:cNvSpPr/>
           <p:nvPr/>
         </p:nvSpPr>
@@ -4520,7 +4628,7 @@
       </p:sp>
       <p:sp>
         <p:nvSpPr>
-          <p:cNvPr id="17" name="TextBox 16"/>
+          <p:cNvPr id="18" name="TextBox 17"/>
           <p:cNvSpPr txBox="1"/>
           <p:nvPr/>
         </p:nvSpPr>
@@ -4611,6 +4719,42 @@
         </p:nvSpPr>
         <p:spPr>
           <a:xfrm>
+            <a:off x="9601200" y="6309360"/>
+            <a:ext cx="2057400" cy="365760"/>
+          </a:xfrm>
+          <a:prstGeom prst="rect">
+            <a:avLst/>
+          </a:prstGeom>
+          <a:noFill/>
+        </p:spPr>
+        <p:txBody>
+          <a:bodyPr wrap="none">
+            <a:spAutoFit/>
+          </a:bodyPr>
+          <a:lstStyle/>
+          <a:p>
+            <a:pPr algn="r">
+              <a:defRPr sz="850" b="1">
+                <a:solidFill>
+                  <a:srgbClr val="94A3B8"/>
+                </a:solidFill>
+                <a:latin typeface="Trebuchet MS"/>
+              </a:defRPr>
+            </a:pPr>
+            <a:r>
+              <a:t>BUILT BY SHAKIB</a:t>
+            </a:r>
+          </a:p>
+        </p:txBody>
+      </p:sp>
+      <p:sp>
+        <p:nvSpPr>
+          <p:cNvPr id="3" name="TextBox 2"/>
+          <p:cNvSpPr txBox="1"/>
+          <p:nvPr/>
+        </p:nvSpPr>
+        <p:spPr>
+          <a:xfrm>
             <a:off x="548640" y="365760"/>
             <a:ext cx="10972800" cy="365760"/>
           </a:xfrm>
@@ -4641,7 +4785,7 @@
       </p:sp>
       <p:sp>
         <p:nvSpPr>
-          <p:cNvPr id="3" name="TextBox 2"/>
+          <p:cNvPr id="4" name="TextBox 3"/>
           <p:cNvSpPr txBox="1"/>
           <p:nvPr/>
         </p:nvSpPr>
@@ -4677,7 +4821,7 @@
       </p:sp>
       <p:sp>
         <p:nvSpPr>
-          <p:cNvPr id="4" name="Rectangle 3"/>
+          <p:cNvPr id="5" name="Rectangle 4"/>
           <p:cNvSpPr/>
           <p:nvPr/>
         </p:nvSpPr>
@@ -4720,7 +4864,7 @@
       </p:sp>
       <p:sp>
         <p:nvSpPr>
-          <p:cNvPr id="5" name="Rounded Rectangle 4"/>
+          <p:cNvPr id="6" name="Rounded Rectangle 5"/>
           <p:cNvSpPr/>
           <p:nvPr/>
         </p:nvSpPr>
@@ -4765,7 +4909,7 @@
       </p:sp>
       <p:sp>
         <p:nvSpPr>
-          <p:cNvPr id="6" name="TextBox 5"/>
+          <p:cNvPr id="7" name="TextBox 6"/>
           <p:cNvSpPr txBox="1"/>
           <p:nvPr/>
         </p:nvSpPr>
@@ -4825,7 +4969,7 @@
       </p:sp>
       <p:sp>
         <p:nvSpPr>
-          <p:cNvPr id="7" name="Rounded Rectangle 6"/>
+          <p:cNvPr id="8" name="Rounded Rectangle 7"/>
           <p:cNvSpPr/>
           <p:nvPr/>
         </p:nvSpPr>
@@ -4870,7 +5014,7 @@
       </p:sp>
       <p:sp>
         <p:nvSpPr>
-          <p:cNvPr id="8" name="TextBox 7"/>
+          <p:cNvPr id="9" name="TextBox 8"/>
           <p:cNvSpPr txBox="1"/>
           <p:nvPr/>
         </p:nvSpPr>
@@ -4930,7 +5074,7 @@
       </p:sp>
       <p:sp>
         <p:nvSpPr>
-          <p:cNvPr id="9" name="Rounded Rectangle 8"/>
+          <p:cNvPr id="10" name="Rounded Rectangle 9"/>
           <p:cNvSpPr/>
           <p:nvPr/>
         </p:nvSpPr>
@@ -4975,7 +5119,7 @@
       </p:sp>
       <p:sp>
         <p:nvSpPr>
-          <p:cNvPr id="10" name="TextBox 9"/>
+          <p:cNvPr id="11" name="TextBox 10"/>
           <p:cNvSpPr txBox="1"/>
           <p:nvPr/>
         </p:nvSpPr>
@@ -5039,7 +5183,7 @@
       </p:sp>
       <p:sp>
         <p:nvSpPr>
-          <p:cNvPr id="11" name="TextBox 10"/>
+          <p:cNvPr id="12" name="TextBox 11"/>
           <p:cNvSpPr txBox="1"/>
           <p:nvPr/>
         </p:nvSpPr>
@@ -5122,6 +5266,42 @@
         </p:nvSpPr>
         <p:spPr>
           <a:xfrm>
+            <a:off x="9601200" y="6309360"/>
+            <a:ext cx="2057400" cy="365760"/>
+          </a:xfrm>
+          <a:prstGeom prst="rect">
+            <a:avLst/>
+          </a:prstGeom>
+          <a:noFill/>
+        </p:spPr>
+        <p:txBody>
+          <a:bodyPr wrap="none">
+            <a:spAutoFit/>
+          </a:bodyPr>
+          <a:lstStyle/>
+          <a:p>
+            <a:pPr algn="r">
+              <a:defRPr sz="850" b="1">
+                <a:solidFill>
+                  <a:srgbClr val="94A3B8"/>
+                </a:solidFill>
+                <a:latin typeface="Trebuchet MS"/>
+              </a:defRPr>
+            </a:pPr>
+            <a:r>
+              <a:t>BUILT BY SHAKIB</a:t>
+            </a:r>
+          </a:p>
+        </p:txBody>
+      </p:sp>
+      <p:sp>
+        <p:nvSpPr>
+          <p:cNvPr id="3" name="TextBox 2"/>
+          <p:cNvSpPr txBox="1"/>
+          <p:nvPr/>
+        </p:nvSpPr>
+        <p:spPr>
+          <a:xfrm>
             <a:off x="548640" y="365760"/>
             <a:ext cx="10972800" cy="365760"/>
           </a:xfrm>
@@ -5152,7 +5332,7 @@
       </p:sp>
       <p:sp>
         <p:nvSpPr>
-          <p:cNvPr id="3" name="TextBox 2"/>
+          <p:cNvPr id="4" name="TextBox 3"/>
           <p:cNvSpPr txBox="1"/>
           <p:nvPr/>
         </p:nvSpPr>
@@ -5188,7 +5368,7 @@
       </p:sp>
       <p:sp>
         <p:nvSpPr>
-          <p:cNvPr id="4" name="Rectangle 3"/>
+          <p:cNvPr id="5" name="Rectangle 4"/>
           <p:cNvSpPr/>
           <p:nvPr/>
         </p:nvSpPr>
@@ -5231,7 +5411,7 @@
       </p:sp>
       <p:sp>
         <p:nvSpPr>
-          <p:cNvPr id="5" name="Rounded Rectangle 4"/>
+          <p:cNvPr id="6" name="Rounded Rectangle 5"/>
           <p:cNvSpPr/>
           <p:nvPr/>
         </p:nvSpPr>
@@ -5276,7 +5456,7 @@
       </p:sp>
       <p:sp>
         <p:nvSpPr>
-          <p:cNvPr id="6" name="TextBox 5"/>
+          <p:cNvPr id="7" name="TextBox 6"/>
           <p:cNvSpPr txBox="1"/>
           <p:nvPr/>
         </p:nvSpPr>
@@ -5324,7 +5504,7 @@
       </p:sp>
       <p:sp>
         <p:nvSpPr>
-          <p:cNvPr id="7" name="TextBox 6"/>
+          <p:cNvPr id="8" name="TextBox 7"/>
           <p:cNvSpPr txBox="1"/>
           <p:nvPr/>
         </p:nvSpPr>
@@ -5359,7 +5539,7 @@
       </p:sp>
       <p:sp>
         <p:nvSpPr>
-          <p:cNvPr id="8" name="Rounded Rectangle 7"/>
+          <p:cNvPr id="9" name="Rounded Rectangle 8"/>
           <p:cNvSpPr/>
           <p:nvPr/>
         </p:nvSpPr>
@@ -5404,7 +5584,7 @@
       </p:sp>
       <p:sp>
         <p:nvSpPr>
-          <p:cNvPr id="9" name="TextBox 8"/>
+          <p:cNvPr id="10" name="TextBox 9"/>
           <p:cNvSpPr txBox="1"/>
           <p:nvPr/>
         </p:nvSpPr>
@@ -5452,7 +5632,7 @@
       </p:sp>
       <p:sp>
         <p:nvSpPr>
-          <p:cNvPr id="10" name="TextBox 9"/>
+          <p:cNvPr id="11" name="TextBox 10"/>
           <p:cNvSpPr txBox="1"/>
           <p:nvPr/>
         </p:nvSpPr>
@@ -5487,7 +5667,7 @@
       </p:sp>
       <p:sp>
         <p:nvSpPr>
-          <p:cNvPr id="11" name="Rounded Rectangle 10"/>
+          <p:cNvPr id="12" name="Rounded Rectangle 11"/>
           <p:cNvSpPr/>
           <p:nvPr/>
         </p:nvSpPr>
@@ -5532,7 +5712,7 @@
       </p:sp>
       <p:sp>
         <p:nvSpPr>
-          <p:cNvPr id="12" name="TextBox 11"/>
+          <p:cNvPr id="13" name="TextBox 12"/>
           <p:cNvSpPr txBox="1"/>
           <p:nvPr/>
         </p:nvSpPr>
@@ -5580,7 +5760,7 @@
       </p:sp>
       <p:sp>
         <p:nvSpPr>
-          <p:cNvPr id="13" name="TextBox 12"/>
+          <p:cNvPr id="14" name="TextBox 13"/>
           <p:cNvSpPr txBox="1"/>
           <p:nvPr/>
         </p:nvSpPr>
@@ -5615,7 +5795,7 @@
       </p:sp>
       <p:sp>
         <p:nvSpPr>
-          <p:cNvPr id="14" name="Rounded Rectangle 13"/>
+          <p:cNvPr id="15" name="Rounded Rectangle 14"/>
           <p:cNvSpPr/>
           <p:nvPr/>
         </p:nvSpPr>
@@ -5660,7 +5840,7 @@
       </p:sp>
       <p:sp>
         <p:nvSpPr>
-          <p:cNvPr id="15" name="TextBox 14"/>
+          <p:cNvPr id="16" name="TextBox 15"/>
           <p:cNvSpPr txBox="1"/>
           <p:nvPr/>
         </p:nvSpPr>
@@ -5708,7 +5888,7 @@
       </p:sp>
       <p:sp>
         <p:nvSpPr>
-          <p:cNvPr id="16" name="TextBox 15"/>
+          <p:cNvPr id="17" name="TextBox 16"/>
           <p:cNvSpPr txBox="1"/>
           <p:nvPr/>
         </p:nvSpPr>
@@ -5743,7 +5923,7 @@
       </p:sp>
       <p:sp>
         <p:nvSpPr>
-          <p:cNvPr id="17" name="Rounded Rectangle 16"/>
+          <p:cNvPr id="18" name="Rounded Rectangle 17"/>
           <p:cNvSpPr/>
           <p:nvPr/>
         </p:nvSpPr>
@@ -5788,7 +5968,7 @@
       </p:sp>
       <p:sp>
         <p:nvSpPr>
-          <p:cNvPr id="18" name="TextBox 17"/>
+          <p:cNvPr id="19" name="TextBox 18"/>
           <p:cNvSpPr txBox="1"/>
           <p:nvPr/>
         </p:nvSpPr>
@@ -5836,7 +6016,7 @@
       </p:sp>
       <p:sp>
         <p:nvSpPr>
-          <p:cNvPr id="19" name="TextBox 18"/>
+          <p:cNvPr id="20" name="TextBox 19"/>
           <p:cNvSpPr txBox="1"/>
           <p:nvPr/>
         </p:nvSpPr>
@@ -5871,7 +6051,7 @@
       </p:sp>
       <p:sp>
         <p:nvSpPr>
-          <p:cNvPr id="20" name="Rounded Rectangle 19"/>
+          <p:cNvPr id="21" name="Rounded Rectangle 20"/>
           <p:cNvSpPr/>
           <p:nvPr/>
         </p:nvSpPr>
@@ -5916,7 +6096,7 @@
       </p:sp>
       <p:sp>
         <p:nvSpPr>
-          <p:cNvPr id="21" name="TextBox 20"/>
+          <p:cNvPr id="22" name="TextBox 21"/>
           <p:cNvSpPr txBox="1"/>
           <p:nvPr/>
         </p:nvSpPr>
@@ -5964,7 +6144,7 @@
       </p:sp>
       <p:sp>
         <p:nvSpPr>
-          <p:cNvPr id="22" name="TextBox 21"/>
+          <p:cNvPr id="23" name="TextBox 22"/>
           <p:cNvSpPr txBox="1"/>
           <p:nvPr/>
         </p:nvSpPr>
@@ -5999,7 +6179,7 @@
       </p:sp>
       <p:sp>
         <p:nvSpPr>
-          <p:cNvPr id="23" name="Rounded Rectangle 22"/>
+          <p:cNvPr id="24" name="Rounded Rectangle 23"/>
           <p:cNvSpPr/>
           <p:nvPr/>
         </p:nvSpPr>
@@ -6044,7 +6224,7 @@
       </p:sp>
       <p:sp>
         <p:nvSpPr>
-          <p:cNvPr id="24" name="TextBox 23"/>
+          <p:cNvPr id="25" name="TextBox 24"/>
           <p:cNvSpPr txBox="1"/>
           <p:nvPr/>
         </p:nvSpPr>
@@ -6092,7 +6272,7 @@
       </p:sp>
       <p:sp>
         <p:nvSpPr>
-          <p:cNvPr id="25" name="Rectangle 24"/>
+          <p:cNvPr id="26" name="Rectangle 25"/>
           <p:cNvSpPr/>
           <p:nvPr/>
         </p:nvSpPr>
@@ -6137,7 +6317,7 @@
       </p:sp>
       <p:sp>
         <p:nvSpPr>
-          <p:cNvPr id="26" name="TextBox 25"/>
+          <p:cNvPr id="27" name="TextBox 26"/>
           <p:cNvSpPr txBox="1"/>
           <p:nvPr/>
         </p:nvSpPr>
@@ -6224,6 +6404,42 @@
         </p:nvSpPr>
         <p:spPr>
           <a:xfrm>
+            <a:off x="9601200" y="6309360"/>
+            <a:ext cx="2057400" cy="365760"/>
+          </a:xfrm>
+          <a:prstGeom prst="rect">
+            <a:avLst/>
+          </a:prstGeom>
+          <a:noFill/>
+        </p:spPr>
+        <p:txBody>
+          <a:bodyPr wrap="none">
+            <a:spAutoFit/>
+          </a:bodyPr>
+          <a:lstStyle/>
+          <a:p>
+            <a:pPr algn="r">
+              <a:defRPr sz="850" b="1">
+                <a:solidFill>
+                  <a:srgbClr val="94A3B8"/>
+                </a:solidFill>
+                <a:latin typeface="Trebuchet MS"/>
+              </a:defRPr>
+            </a:pPr>
+            <a:r>
+              <a:t>BUILT BY SHAKIB</a:t>
+            </a:r>
+          </a:p>
+        </p:txBody>
+      </p:sp>
+      <p:sp>
+        <p:nvSpPr>
+          <p:cNvPr id="3" name="TextBox 2"/>
+          <p:cNvSpPr txBox="1"/>
+          <p:nvPr/>
+        </p:nvSpPr>
+        <p:spPr>
+          <a:xfrm>
             <a:off x="548640" y="365760"/>
             <a:ext cx="10972800" cy="365760"/>
           </a:xfrm>
@@ -6254,7 +6470,7 @@
       </p:sp>
       <p:sp>
         <p:nvSpPr>
-          <p:cNvPr id="3" name="TextBox 2"/>
+          <p:cNvPr id="4" name="TextBox 3"/>
           <p:cNvSpPr txBox="1"/>
           <p:nvPr/>
         </p:nvSpPr>
@@ -6290,7 +6506,7 @@
       </p:sp>
       <p:sp>
         <p:nvSpPr>
-          <p:cNvPr id="4" name="Rectangle 3"/>
+          <p:cNvPr id="5" name="Rectangle 4"/>
           <p:cNvSpPr/>
           <p:nvPr/>
         </p:nvSpPr>
@@ -6333,7 +6549,7 @@
       </p:sp>
       <p:sp>
         <p:nvSpPr>
-          <p:cNvPr id="5" name="Rounded Rectangle 4"/>
+          <p:cNvPr id="6" name="Rounded Rectangle 5"/>
           <p:cNvSpPr/>
           <p:nvPr/>
         </p:nvSpPr>
@@ -6378,7 +6594,7 @@
       </p:sp>
       <p:sp>
         <p:nvSpPr>
-          <p:cNvPr id="6" name="TextBox 5"/>
+          <p:cNvPr id="7" name="TextBox 6"/>
           <p:cNvSpPr txBox="1"/>
           <p:nvPr/>
         </p:nvSpPr>
@@ -6443,7 +6659,7 @@
       </p:sp>
       <p:sp>
         <p:nvSpPr>
-          <p:cNvPr id="7" name="Rounded Rectangle 6"/>
+          <p:cNvPr id="8" name="Rounded Rectangle 7"/>
           <p:cNvSpPr/>
           <p:nvPr/>
         </p:nvSpPr>
@@ -6488,7 +6704,7 @@
       </p:sp>
       <p:sp>
         <p:nvSpPr>
-          <p:cNvPr id="8" name="TextBox 7"/>
+          <p:cNvPr id="9" name="TextBox 8"/>
           <p:cNvSpPr txBox="1"/>
           <p:nvPr/>
         </p:nvSpPr>
@@ -6589,6 +6805,42 @@
         </p:nvSpPr>
         <p:spPr>
           <a:xfrm>
+            <a:off x="9601200" y="6309360"/>
+            <a:ext cx="2057400" cy="365760"/>
+          </a:xfrm>
+          <a:prstGeom prst="rect">
+            <a:avLst/>
+          </a:prstGeom>
+          <a:noFill/>
+        </p:spPr>
+        <p:txBody>
+          <a:bodyPr wrap="none">
+            <a:spAutoFit/>
+          </a:bodyPr>
+          <a:lstStyle/>
+          <a:p>
+            <a:pPr algn="r">
+              <a:defRPr sz="850" b="1">
+                <a:solidFill>
+                  <a:srgbClr val="94A3B8"/>
+                </a:solidFill>
+                <a:latin typeface="Trebuchet MS"/>
+              </a:defRPr>
+            </a:pPr>
+            <a:r>
+              <a:t>BUILT BY SHAKIB</a:t>
+            </a:r>
+          </a:p>
+        </p:txBody>
+      </p:sp>
+      <p:sp>
+        <p:nvSpPr>
+          <p:cNvPr id="3" name="TextBox 2"/>
+          <p:cNvSpPr txBox="1"/>
+          <p:nvPr/>
+        </p:nvSpPr>
+        <p:spPr>
+          <a:xfrm>
             <a:off x="548640" y="365760"/>
             <a:ext cx="10972800" cy="365760"/>
           </a:xfrm>
@@ -6619,7 +6871,7 @@
       </p:sp>
       <p:sp>
         <p:nvSpPr>
-          <p:cNvPr id="3" name="TextBox 2"/>
+          <p:cNvPr id="4" name="TextBox 3"/>
           <p:cNvSpPr txBox="1"/>
           <p:nvPr/>
         </p:nvSpPr>
@@ -6655,7 +6907,7 @@
       </p:sp>
       <p:sp>
         <p:nvSpPr>
-          <p:cNvPr id="4" name="Rectangle 3"/>
+          <p:cNvPr id="5" name="Rectangle 4"/>
           <p:cNvSpPr/>
           <p:nvPr/>
         </p:nvSpPr>
@@ -6698,7 +6950,7 @@
       </p:sp>
       <p:sp>
         <p:nvSpPr>
-          <p:cNvPr id="5" name="Rounded Rectangle 4"/>
+          <p:cNvPr id="6" name="Rounded Rectangle 5"/>
           <p:cNvSpPr/>
           <p:nvPr/>
         </p:nvSpPr>
@@ -6743,7 +6995,7 @@
       </p:sp>
       <p:sp>
         <p:nvSpPr>
-          <p:cNvPr id="6" name="TextBox 5"/>
+          <p:cNvPr id="7" name="TextBox 6"/>
           <p:cNvSpPr txBox="1"/>
           <p:nvPr/>
         </p:nvSpPr>
@@ -6803,7 +7055,7 @@
       </p:sp>
       <p:sp>
         <p:nvSpPr>
-          <p:cNvPr id="7" name="Rounded Rectangle 6"/>
+          <p:cNvPr id="8" name="Rounded Rectangle 7"/>
           <p:cNvSpPr/>
           <p:nvPr/>
         </p:nvSpPr>
@@ -6848,7 +7100,7 @@
       </p:sp>
       <p:sp>
         <p:nvSpPr>
-          <p:cNvPr id="8" name="TextBox 7"/>
+          <p:cNvPr id="9" name="TextBox 8"/>
           <p:cNvSpPr txBox="1"/>
           <p:nvPr/>
         </p:nvSpPr>
@@ -6969,6 +7221,42 @@
         </p:nvSpPr>
         <p:spPr>
           <a:xfrm>
+            <a:off x="9601200" y="6309360"/>
+            <a:ext cx="2057400" cy="365760"/>
+          </a:xfrm>
+          <a:prstGeom prst="rect">
+            <a:avLst/>
+          </a:prstGeom>
+          <a:noFill/>
+        </p:spPr>
+        <p:txBody>
+          <a:bodyPr wrap="none">
+            <a:spAutoFit/>
+          </a:bodyPr>
+          <a:lstStyle/>
+          <a:p>
+            <a:pPr algn="r">
+              <a:defRPr sz="850" b="1">
+                <a:solidFill>
+                  <a:srgbClr val="94A3B8"/>
+                </a:solidFill>
+                <a:latin typeface="Trebuchet MS"/>
+              </a:defRPr>
+            </a:pPr>
+            <a:r>
+              <a:t>BUILT BY SHAKIB</a:t>
+            </a:r>
+          </a:p>
+        </p:txBody>
+      </p:sp>
+      <p:sp>
+        <p:nvSpPr>
+          <p:cNvPr id="3" name="TextBox 2"/>
+          <p:cNvSpPr txBox="1"/>
+          <p:nvPr/>
+        </p:nvSpPr>
+        <p:spPr>
+          <a:xfrm>
             <a:off x="548640" y="365760"/>
             <a:ext cx="10972800" cy="365760"/>
           </a:xfrm>
@@ -6999,7 +7287,7 @@
       </p:sp>
       <p:sp>
         <p:nvSpPr>
-          <p:cNvPr id="3" name="TextBox 2"/>
+          <p:cNvPr id="4" name="TextBox 3"/>
           <p:cNvSpPr txBox="1"/>
           <p:nvPr/>
         </p:nvSpPr>
@@ -7035,7 +7323,7 @@
       </p:sp>
       <p:sp>
         <p:nvSpPr>
-          <p:cNvPr id="4" name="Rectangle 3"/>
+          <p:cNvPr id="5" name="Rectangle 4"/>
           <p:cNvSpPr/>
           <p:nvPr/>
         </p:nvSpPr>
@@ -7078,7 +7366,7 @@
       </p:sp>
       <p:sp>
         <p:nvSpPr>
-          <p:cNvPr id="5" name="Rounded Rectangle 4"/>
+          <p:cNvPr id="6" name="Rounded Rectangle 5"/>
           <p:cNvSpPr/>
           <p:nvPr/>
         </p:nvSpPr>
@@ -7123,7 +7411,7 @@
       </p:sp>
       <p:sp>
         <p:nvSpPr>
-          <p:cNvPr id="6" name="TextBox 5"/>
+          <p:cNvPr id="7" name="TextBox 6"/>
           <p:cNvSpPr txBox="1"/>
           <p:nvPr/>
         </p:nvSpPr>
@@ -7203,7 +7491,7 @@
       </p:sp>
       <p:sp>
         <p:nvSpPr>
-          <p:cNvPr id="7" name="Rounded Rectangle 6"/>
+          <p:cNvPr id="8" name="Rounded Rectangle 7"/>
           <p:cNvSpPr/>
           <p:nvPr/>
         </p:nvSpPr>
@@ -7248,7 +7536,7 @@
       </p:sp>
       <p:sp>
         <p:nvSpPr>
-          <p:cNvPr id="8" name="TextBox 7"/>
+          <p:cNvPr id="9" name="TextBox 8"/>
           <p:cNvSpPr txBox="1"/>
           <p:nvPr/>
         </p:nvSpPr>
@@ -7351,6 +7639,42 @@
       <p:sp>
         <p:nvSpPr>
           <p:cNvPr id="2" name="TextBox 1"/>
+          <p:cNvSpPr txBox="1"/>
+          <p:nvPr/>
+        </p:nvSpPr>
+        <p:spPr>
+          <a:xfrm>
+            <a:off x="9601200" y="6309360"/>
+            <a:ext cx="2057400" cy="365760"/>
+          </a:xfrm>
+          <a:prstGeom prst="rect">
+            <a:avLst/>
+          </a:prstGeom>
+          <a:noFill/>
+        </p:spPr>
+        <p:txBody>
+          <a:bodyPr wrap="none">
+            <a:spAutoFit/>
+          </a:bodyPr>
+          <a:lstStyle/>
+          <a:p>
+            <a:pPr algn="r">
+              <a:defRPr sz="850" b="1">
+                <a:solidFill>
+                  <a:srgbClr val="94A3B8"/>
+                </a:solidFill>
+                <a:latin typeface="Trebuchet MS"/>
+              </a:defRPr>
+            </a:pPr>
+            <a:r>
+              <a:t>BUILT BY SHAKIB</a:t>
+            </a:r>
+          </a:p>
+        </p:txBody>
+      </p:sp>
+      <p:sp>
+        <p:nvSpPr>
+          <p:cNvPr id="3" name="TextBox 2"/>
           <p:cNvSpPr txBox="1"/>
           <p:nvPr/>
         </p:nvSpPr>

</xml_diff>

<commit_message>
Update title slide with team members and UIU university name
</commit_message>
<xml_diff>
--- a/Multilingual_HTR_Presentation.pptx
+++ b/Multilingual_HTR_Presentation.pptx
@@ -3171,7 +3171,7 @@
               </a:defRPr>
             </a:pPr>
             <a:r>
-              <a:t>RESEARCH PROPOSAL • CSE FYDP</a:t>
+              <a:t>RESEARCH PROJECT • CSE</a:t>
             </a:r>
           </a:p>
           <a:p>
@@ -3229,8 +3229,8 @@
         </p:nvSpPr>
         <p:spPr>
           <a:xfrm>
-            <a:off x="731520" y="5029200"/>
-            <a:ext cx="5943600" cy="1371600"/>
+            <a:off x="731520" y="4663440"/>
+            <a:ext cx="5943600" cy="1828800"/>
           </a:xfrm>
           <a:prstGeom prst="rect">
             <a:avLst/>
@@ -3244,7 +3244,7 @@
           <a:lstStyle/>
           <a:p>
             <a:pPr>
-              <a:defRPr sz="1100">
+              <a:defRPr sz="1000">
                 <a:solidFill>
                   <a:srgbClr val="94A3B8"/>
                 </a:solidFill>
@@ -3256,7 +3256,11 @@
             </a:r>
             <a:br/>
             <a:r>
-              <a:t>Team Members &amp; IDs</a:t>
+              <a:t>MD SHAKIB AHMED (112230862)  •  Md Fahad Molla (112230890)</a:t>
+            </a:r>
+            <a:br/>
+            <a:r>
+              <a:t>Muhammad Yeakub (112231003)  •  Md. Imjam Hosen (112230335)</a:t>
             </a:r>
             <a:br/>
             <a:br/>
@@ -3265,7 +3269,7 @@
             </a:r>
             <a:br/>
             <a:r>
-              <a:t>University Name</a:t>
+              <a:t>United International University</a:t>
             </a:r>
           </a:p>
         </p:txBody>

</xml_diff>